<commit_message>
Simplify documentary comparisons and clean public PowerPoint copy
</commit_message>
<xml_diff>
--- a/cloudwalk-fidcs-auditoria-clean.pptx
+++ b/cloudwalk-fidcs-auditoria-clean.pptx
@@ -1692,7 +1692,7 @@
                   <a:srgbClr val="06080D"/>
                 </a:solidFill>
               </a:rPr>
-              <a:t>premissa manual crítica</a:t>
+              <a:t>premissa de spread</a:t>
             </a:r>
           </a:p>
         </p:txBody>
@@ -3802,7 +3802,7 @@
                   <a:srgbClr val="06080D"/>
                 </a:solidFill>
               </a:rPr>
-              <a:t>Manter CDI+ informado manualmente pelo usuário, com asterisco.</a:t>
+              <a:t>Spread sujeito à validação documental.</a:t>
             </a:r>
           </a:p>
         </p:txBody>
@@ -5448,7 +5448,7 @@
                   <a:srgbClr val="06080D"/>
                 </a:solidFill>
               </a:rPr>
-              <a:t>Big Picture é input manual</a:t>
+              <a:t>Big Picture: spread a validar</a:t>
             </a:r>
           </a:p>
         </p:txBody>
@@ -5497,7 +5497,7 @@
                   <a:srgbClr val="4F5661"/>
                 </a:solidFill>
               </a:rPr>
-              <a:t>1,20% / 1,50% / 1,90% / 3,00% informados pelo usuário.</a:t>
+              <a:t>1,20% / 1,50% / 1,90% / 3,00%</a:t>
             </a:r>
           </a:p>
         </p:txBody>
@@ -6793,7 +6793,7 @@
                   <a:srgbClr val="06080D"/>
                 </a:solidFill>
               </a:rPr>
-              <a:t>G1 bancos; spread manual</a:t>
+              <a:t>G1 bancos; spread a validar</a:t>
             </a:r>
           </a:p>
         </p:txBody>
@@ -11990,7 +11990,7 @@
                   <a:srgbClr val="4F5661"/>
                 </a:solidFill>
               </a:rPr>
-              <a:t>* n.l. = não localizado em PDF baixado. Sub/Jr de Bela é derivado por subordinação-alvo, não observado como oferta CVM; Big Picture CDI+ é input manual informado pelo usuário.</a:t>
+              <a:t>* n.l. = não localizado em PDF baixado. Sub/Jr de Bela é derivado por subordinação-alvo, não observado como oferta CVM.</a:t>
             </a:r>
           </a:p>
         </p:txBody>
@@ -15429,7 +15429,7 @@
                   <a:srgbClr val="06080D"/>
                 </a:solidFill>
               </a:rPr>
-              <a:t>Big Pictures têm menor evidência de custo nos PDFs baixados; os spreads continuam como input manual.</a:t>
+              <a:t>Big Pictures têm menor evidência de custo nos PDFs baixados.</a:t>
             </a:r>
           </a:p>
         </p:txBody>

</xml_diff>